<commit_message>
Fix deck responsiveness and PPTX slide overflow
HTML decks:
- Mobile-first layout that adapts to the viewport instead of scaling a
  fixed 16:9 canvas down; switches to a framed 16:9 slide with
  container-query-unit text sizing only on larger landscape screens
- Text now always fits the slide (cqh units) so nothing overflows the canvas
- Added a 'best on desktop / rotate to landscape' hint on small portrait screens
- Larger tap targets for slide nav

PPTX decks:
- Constrain diagram images by height so they never run past the slide edge
- Trim font sizes and box geometry for safe vertical fit
- Verified every shape stays within the 7.5in slide bounds
</commit_message>
<xml_diff>
--- a/public/teach/decks/agent-skills-101.pptx
+++ b/public/teach/decks/agent-skills-101.pptx
@@ -3146,8 +3146,8 @@
         </p:nvSpPr>
         <p:spPr>
           <a:xfrm>
-            <a:off x="822960" y="1920240"/>
-            <a:ext cx="10515600" cy="1828800"/>
+            <a:off x="822960" y="1874519"/>
+            <a:ext cx="10607040" cy="1920240"/>
           </a:xfrm>
           <a:prstGeom prst="rect">
             <a:avLst/>
@@ -3166,7 +3166,7 @@
               </a:lnSpc>
             </a:pPr>
             <a:r>
-              <a:rPr sz="6600" b="1">
+              <a:rPr sz="5800" b="1">
                 <a:solidFill>
                   <a:srgbClr val="FFFFFF"/>
                 </a:solidFill>
@@ -3185,8 +3185,8 @@
         </p:nvSpPr>
         <p:spPr>
           <a:xfrm>
-            <a:off x="822960" y="3840480"/>
-            <a:ext cx="8686800" cy="1188720"/>
+            <a:off x="822960" y="3886200"/>
+            <a:ext cx="9144000" cy="1188720"/>
           </a:xfrm>
           <a:prstGeom prst="rect">
             <a:avLst/>
@@ -3205,7 +3205,7 @@
               </a:lnSpc>
             </a:pPr>
             <a:r>
-              <a:rPr sz="2400" b="0">
+              <a:rPr sz="2300" b="0">
                 <a:solidFill>
                   <a:srgbClr val="A1A1A1"/>
                 </a:solidFill>
@@ -3224,8 +3224,8 @@
         </p:nvSpPr>
         <p:spPr>
           <a:xfrm>
-            <a:off x="822960" y="5212080"/>
-            <a:ext cx="8229600" cy="548640"/>
+            <a:off x="822960" y="5257800"/>
+            <a:ext cx="9144000" cy="548640"/>
           </a:xfrm>
           <a:prstGeom prst="rect">
             <a:avLst/>
@@ -3434,7 +3434,7 @@
         <p:spPr>
           <a:xfrm>
             <a:off x="822960" y="1828800"/>
-            <a:ext cx="10058400" cy="2194560"/>
+            <a:ext cx="10424160" cy="2377440"/>
           </a:xfrm>
           <a:prstGeom prst="rect">
             <a:avLst/>
@@ -3449,11 +3449,11 @@
           <a:p>
             <a:pPr algn="l">
               <a:lnSpc>
-                <a:spcPct val="102000"/>
+                <a:spcPct val="104000"/>
               </a:lnSpc>
             </a:pPr>
             <a:r>
-              <a:rPr sz="5200" b="1">
+              <a:rPr sz="4400" b="1">
                 <a:solidFill>
                   <a:srgbClr val="FFFFFF"/>
                 </a:solidFill>
@@ -3472,8 +3472,8 @@
         </p:nvSpPr>
         <p:spPr>
           <a:xfrm>
-            <a:off x="822960" y="4297680"/>
-            <a:ext cx="9144000" cy="1463040"/>
+            <a:off x="822960" y="4526280"/>
+            <a:ext cx="9509760" cy="1463040"/>
           </a:xfrm>
           <a:prstGeom prst="rect">
             <a:avLst/>
@@ -3492,7 +3492,7 @@
               </a:lnSpc>
             </a:pPr>
             <a:r>
-              <a:rPr sz="2200" b="0">
+              <a:rPr sz="2100" b="0">
                 <a:solidFill>
                   <a:srgbClr val="A1A1A1"/>
                 </a:solidFill>
@@ -3685,8 +3685,8 @@
         </p:nvSpPr>
         <p:spPr>
           <a:xfrm>
-            <a:off x="822960" y="1371600"/>
-            <a:ext cx="10515600" cy="1097280"/>
+            <a:off x="822960" y="1325880"/>
+            <a:ext cx="10607040" cy="1005840"/>
           </a:xfrm>
           <a:prstGeom prst="rect">
             <a:avLst/>
@@ -3705,7 +3705,7 @@
               </a:lnSpc>
             </a:pPr>
             <a:r>
-              <a:rPr sz="4000" b="1">
+              <a:rPr sz="3600" b="1">
                 <a:solidFill>
                   <a:srgbClr val="FFFFFF"/>
                 </a:solidFill>
@@ -3724,8 +3724,8 @@
         </p:nvSpPr>
         <p:spPr>
           <a:xfrm>
-            <a:off x="822960" y="2743200"/>
-            <a:ext cx="10424160" cy="3291840"/>
+            <a:off x="822960" y="2606040"/>
+            <a:ext cx="10515600" cy="3566160"/>
           </a:xfrm>
           <a:prstGeom prst="rect">
             <a:avLst/>
@@ -3740,14 +3740,14 @@
           <a:p>
             <a:pPr>
               <a:lnSpc>
-                <a:spcPct val="115000"/>
+                <a:spcPct val="112000"/>
               </a:lnSpc>
               <a:spcAft>
-                <a:spcPts val="1400"/>
+                <a:spcPts val="1000"/>
               </a:spcAft>
             </a:pPr>
             <a:r>
-              <a:rPr sz="2200">
+              <a:rPr sz="1900">
                 <a:solidFill>
                   <a:srgbClr val="52A8FF"/>
                 </a:solidFill>
@@ -3756,7 +3756,7 @@
               <a:t>-  </a:t>
             </a:r>
             <a:r>
-              <a:rPr sz="2200">
+              <a:rPr sz="1900">
                 <a:solidFill>
                   <a:srgbClr val="EDEDED"/>
                 </a:solidFill>
@@ -3768,14 +3768,14 @@
           <a:p>
             <a:pPr>
               <a:lnSpc>
-                <a:spcPct val="115000"/>
+                <a:spcPct val="112000"/>
               </a:lnSpc>
               <a:spcAft>
-                <a:spcPts val="1400"/>
+                <a:spcPts val="1000"/>
               </a:spcAft>
             </a:pPr>
             <a:r>
-              <a:rPr sz="2200">
+              <a:rPr sz="1900">
                 <a:solidFill>
                   <a:srgbClr val="52A8FF"/>
                 </a:solidFill>
@@ -3784,7 +3784,7 @@
               <a:t>-  </a:t>
             </a:r>
             <a:r>
-              <a:rPr sz="2200">
+              <a:rPr sz="1900">
                 <a:solidFill>
                   <a:srgbClr val="EDEDED"/>
                 </a:solidFill>
@@ -3796,14 +3796,14 @@
           <a:p>
             <a:pPr>
               <a:lnSpc>
-                <a:spcPct val="115000"/>
+                <a:spcPct val="112000"/>
               </a:lnSpc>
               <a:spcAft>
-                <a:spcPts val="1400"/>
+                <a:spcPts val="1000"/>
               </a:spcAft>
             </a:pPr>
             <a:r>
-              <a:rPr sz="2200">
+              <a:rPr sz="1900">
                 <a:solidFill>
                   <a:srgbClr val="52A8FF"/>
                 </a:solidFill>
@@ -3812,7 +3812,7 @@
               <a:t>-  </a:t>
             </a:r>
             <a:r>
-              <a:rPr sz="2200">
+              <a:rPr sz="1900">
                 <a:solidFill>
                   <a:srgbClr val="EDEDED"/>
                 </a:solidFill>
@@ -3824,14 +3824,14 @@
           <a:p>
             <a:pPr>
               <a:lnSpc>
-                <a:spcPct val="115000"/>
+                <a:spcPct val="112000"/>
               </a:lnSpc>
               <a:spcAft>
-                <a:spcPts val="1400"/>
+                <a:spcPts val="1000"/>
               </a:spcAft>
             </a:pPr>
             <a:r>
-              <a:rPr sz="2200">
+              <a:rPr sz="1900">
                 <a:solidFill>
                   <a:srgbClr val="52A8FF"/>
                 </a:solidFill>
@@ -3840,7 +3840,7 @@
               <a:t>-  </a:t>
             </a:r>
             <a:r>
-              <a:rPr sz="2200">
+              <a:rPr sz="1900">
                 <a:solidFill>
                   <a:srgbClr val="EDEDED"/>
                 </a:solidFill>
@@ -4033,8 +4033,8 @@
         </p:nvSpPr>
         <p:spPr>
           <a:xfrm>
-            <a:off x="822960" y="1280160"/>
-            <a:ext cx="10515600" cy="822960"/>
+            <a:off x="822960" y="1207008"/>
+            <a:ext cx="10515600" cy="731520"/>
           </a:xfrm>
           <a:prstGeom prst="rect">
             <a:avLst/>
@@ -4049,7 +4049,7 @@
           <a:p>
             <a:pPr algn="l"/>
             <a:r>
-              <a:rPr sz="3400" b="1">
+              <a:rPr sz="3000" b="1">
                 <a:solidFill>
                   <a:srgbClr val="FFFFFF"/>
                 </a:solidFill>
@@ -4076,8 +4076,8 @@
         </p:blipFill>
         <p:spPr>
           <a:xfrm>
-            <a:off x="822960" y="2148840"/>
-            <a:ext cx="9052560" cy="5092065"/>
+            <a:off x="2804008" y="2057400"/>
+            <a:ext cx="6583680" cy="3703320"/>
           </a:xfrm>
           <a:prstGeom prst="rect">
             <a:avLst/>
@@ -4092,8 +4092,8 @@
         </p:nvSpPr>
         <p:spPr>
           <a:xfrm>
-            <a:off x="822960" y="5806440"/>
-            <a:ext cx="10424160" cy="548640"/>
+            <a:off x="822960" y="5943600"/>
+            <a:ext cx="10515600" cy="457200"/>
           </a:xfrm>
           <a:prstGeom prst="rect">
             <a:avLst/>
@@ -4106,9 +4106,9 @@
           </a:bodyPr>
           <a:lstStyle/>
           <a:p>
-            <a:pPr algn="l"/>
-            <a:r>
-              <a:rPr sz="1500" b="0">
+            <a:pPr algn="ctr"/>
+            <a:r>
+              <a:rPr sz="1400" b="0">
                 <a:solidFill>
                   <a:srgbClr val="7D7D7D"/>
                 </a:solidFill>
@@ -4301,8 +4301,8 @@
         </p:nvSpPr>
         <p:spPr>
           <a:xfrm>
-            <a:off x="822960" y="1280160"/>
-            <a:ext cx="10515600" cy="822960"/>
+            <a:off x="822960" y="1207008"/>
+            <a:ext cx="10515600" cy="731520"/>
           </a:xfrm>
           <a:prstGeom prst="rect">
             <a:avLst/>
@@ -4317,7 +4317,7 @@
           <a:p>
             <a:pPr algn="l"/>
             <a:r>
-              <a:rPr sz="3400" b="1">
+              <a:rPr sz="3000" b="1">
                 <a:solidFill>
                   <a:srgbClr val="FFFFFF"/>
                 </a:solidFill>
@@ -4344,8 +4344,8 @@
         </p:blipFill>
         <p:spPr>
           <a:xfrm>
-            <a:off x="822960" y="2148840"/>
-            <a:ext cx="9052560" cy="5092065"/>
+            <a:off x="2804008" y="2057400"/>
+            <a:ext cx="6583680" cy="3703320"/>
           </a:xfrm>
           <a:prstGeom prst="rect">
             <a:avLst/>
@@ -4360,8 +4360,8 @@
         </p:nvSpPr>
         <p:spPr>
           <a:xfrm>
-            <a:off x="822960" y="5806440"/>
-            <a:ext cx="10424160" cy="548640"/>
+            <a:off x="822960" y="5943600"/>
+            <a:ext cx="10515600" cy="457200"/>
           </a:xfrm>
           <a:prstGeom prst="rect">
             <a:avLst/>
@@ -4374,9 +4374,9 @@
           </a:bodyPr>
           <a:lstStyle/>
           <a:p>
-            <a:pPr algn="l"/>
-            <a:r>
-              <a:rPr sz="1500" b="0">
+            <a:pPr algn="ctr"/>
+            <a:r>
+              <a:rPr sz="1400" b="0">
                 <a:solidFill>
                   <a:srgbClr val="7D7D7D"/>
                 </a:solidFill>
@@ -4569,8 +4569,8 @@
         </p:nvSpPr>
         <p:spPr>
           <a:xfrm>
-            <a:off x="822960" y="1463040"/>
-            <a:ext cx="10515600" cy="1097280"/>
+            <a:off x="822960" y="1417320"/>
+            <a:ext cx="10607040" cy="1005840"/>
           </a:xfrm>
           <a:prstGeom prst="rect">
             <a:avLst/>
@@ -4589,7 +4589,7 @@
               </a:lnSpc>
             </a:pPr>
             <a:r>
-              <a:rPr sz="4000" b="1">
+              <a:rPr sz="3600" b="1">
                 <a:solidFill>
                   <a:srgbClr val="FFFFFF"/>
                 </a:solidFill>
@@ -4608,7 +4608,7 @@
         </p:nvSpPr>
         <p:spPr>
           <a:xfrm>
-            <a:off x="822960" y="2926080"/>
+            <a:off x="822960" y="2880360"/>
             <a:ext cx="7680960" cy="868680"/>
           </a:xfrm>
           <a:prstGeom prst="roundRect">
@@ -4672,8 +4672,8 @@
         </p:nvSpPr>
         <p:spPr>
           <a:xfrm>
-            <a:off x="822960" y="4114800"/>
-            <a:ext cx="9601200" cy="1645920"/>
+            <a:off x="822960" y="4160520"/>
+            <a:ext cx="9692640" cy="1645920"/>
           </a:xfrm>
           <a:prstGeom prst="rect">
             <a:avLst/>
@@ -4692,7 +4692,7 @@
               </a:lnSpc>
             </a:pPr>
             <a:r>
-              <a:rPr sz="2100" b="0">
+              <a:rPr sz="2000" b="0">
                 <a:solidFill>
                   <a:srgbClr val="A1A1A1"/>
                 </a:solidFill>
@@ -4885,8 +4885,8 @@
         </p:nvSpPr>
         <p:spPr>
           <a:xfrm>
-            <a:off x="822960" y="1371600"/>
-            <a:ext cx="10515600" cy="1097280"/>
+            <a:off x="822960" y="1325880"/>
+            <a:ext cx="10607040" cy="1005840"/>
           </a:xfrm>
           <a:prstGeom prst="rect">
             <a:avLst/>
@@ -4905,7 +4905,7 @@
               </a:lnSpc>
             </a:pPr>
             <a:r>
-              <a:rPr sz="4000" b="1">
+              <a:rPr sz="3600" b="1">
                 <a:solidFill>
                   <a:srgbClr val="FFFFFF"/>
                 </a:solidFill>
@@ -4924,8 +4924,8 @@
         </p:nvSpPr>
         <p:spPr>
           <a:xfrm>
-            <a:off x="822960" y="2743200"/>
-            <a:ext cx="10424160" cy="3291840"/>
+            <a:off x="822960" y="2606040"/>
+            <a:ext cx="10515600" cy="3566160"/>
           </a:xfrm>
           <a:prstGeom prst="rect">
             <a:avLst/>
@@ -4940,14 +4940,14 @@
           <a:p>
             <a:pPr>
               <a:lnSpc>
-                <a:spcPct val="115000"/>
+                <a:spcPct val="112000"/>
               </a:lnSpc>
               <a:spcAft>
-                <a:spcPts val="1400"/>
+                <a:spcPts val="1000"/>
               </a:spcAft>
             </a:pPr>
             <a:r>
-              <a:rPr sz="2200">
+              <a:rPr sz="1900">
                 <a:solidFill>
                   <a:srgbClr val="52A8FF"/>
                 </a:solidFill>
@@ -4956,7 +4956,7 @@
               <a:t>-  </a:t>
             </a:r>
             <a:r>
-              <a:rPr sz="2200">
+              <a:rPr sz="1900">
                 <a:solidFill>
                   <a:srgbClr val="EDEDED"/>
                 </a:solidFill>
@@ -4968,14 +4968,14 @@
           <a:p>
             <a:pPr>
               <a:lnSpc>
-                <a:spcPct val="115000"/>
+                <a:spcPct val="112000"/>
               </a:lnSpc>
               <a:spcAft>
-                <a:spcPts val="1400"/>
+                <a:spcPts val="1000"/>
               </a:spcAft>
             </a:pPr>
             <a:r>
-              <a:rPr sz="2200">
+              <a:rPr sz="1900">
                 <a:solidFill>
                   <a:srgbClr val="52A8FF"/>
                 </a:solidFill>
@@ -4984,7 +4984,7 @@
               <a:t>-  </a:t>
             </a:r>
             <a:r>
-              <a:rPr sz="2200">
+              <a:rPr sz="1900">
                 <a:solidFill>
                   <a:srgbClr val="EDEDED"/>
                 </a:solidFill>
@@ -4996,14 +4996,14 @@
           <a:p>
             <a:pPr>
               <a:lnSpc>
-                <a:spcPct val="115000"/>
+                <a:spcPct val="112000"/>
               </a:lnSpc>
               <a:spcAft>
-                <a:spcPts val="1400"/>
+                <a:spcPts val="1000"/>
               </a:spcAft>
             </a:pPr>
             <a:r>
-              <a:rPr sz="2200">
+              <a:rPr sz="1900">
                 <a:solidFill>
                   <a:srgbClr val="52A8FF"/>
                 </a:solidFill>
@@ -5012,7 +5012,7 @@
               <a:t>-  </a:t>
             </a:r>
             <a:r>
-              <a:rPr sz="2200">
+              <a:rPr sz="1900">
                 <a:solidFill>
                   <a:srgbClr val="EDEDED"/>
                 </a:solidFill>
@@ -5024,14 +5024,14 @@
           <a:p>
             <a:pPr>
               <a:lnSpc>
-                <a:spcPct val="115000"/>
+                <a:spcPct val="112000"/>
               </a:lnSpc>
               <a:spcAft>
-                <a:spcPts val="1400"/>
+                <a:spcPts val="1000"/>
               </a:spcAft>
             </a:pPr>
             <a:r>
-              <a:rPr sz="2200">
+              <a:rPr sz="1900">
                 <a:solidFill>
                   <a:srgbClr val="52A8FF"/>
                 </a:solidFill>
@@ -5040,7 +5040,7 @@
               <a:t>-  </a:t>
             </a:r>
             <a:r>
-              <a:rPr sz="2200">
+              <a:rPr sz="1900">
                 <a:solidFill>
                   <a:srgbClr val="EDEDED"/>
                 </a:solidFill>
@@ -5198,7 +5198,7 @@
         </p:nvSpPr>
         <p:spPr>
           <a:xfrm>
-            <a:off x="1097280" y="1828800"/>
+            <a:off x="1097280" y="1783080"/>
             <a:ext cx="9966960" cy="1828800"/>
           </a:xfrm>
           <a:prstGeom prst="rect">
@@ -5218,7 +5218,7 @@
               </a:lnSpc>
             </a:pPr>
             <a:r>
-              <a:rPr sz="4400" b="1">
+              <a:rPr sz="4000" b="1">
                 <a:solidFill>
                   <a:srgbClr val="FFFFFF"/>
                 </a:solidFill>

</xml_diff>